<commit_message>
Clean public course assignment wording
</commit_message>
<xml_diff>
--- a/docs/slides/quantum-routing-algorithm-showcase-final.pptx
+++ b/docs/slides/quantum-routing-algorithm-showcase-final.pptx
@@ -2,19 +2,19 @@
 <file path=ppt/presentation.xml><?xml version="1.0" encoding="utf-8"?>
 <p:presentation xmlns:p="http://schemas.openxmlformats.org/presentationml/2006/main">
   <p:sldMasterIdLst>
-    <p:sldMasterId xmlns:r="http://schemas.openxmlformats.org/officeDocument/2006/relationships" id="2147483648" r:id="Raaaf95b4223443e1"/>
+    <p:sldMasterId xmlns:r="http://schemas.openxmlformats.org/officeDocument/2006/relationships" id="2147483648" r:id="R5947ade9b89a4814"/>
   </p:sldMasterIdLst>
   <p:notesMasterIdLst>
-    <p:notesMasterId xmlns:r="http://schemas.openxmlformats.org/officeDocument/2006/relationships" r:id="Ree237cbd454042b7"/>
+    <p:notesMasterId xmlns:r="http://schemas.openxmlformats.org/officeDocument/2006/relationships" r:id="R864414a2d3234a4d"/>
   </p:notesMasterIdLst>
   <p:sldIdLst>
-    <p:sldId xmlns:r="http://schemas.openxmlformats.org/officeDocument/2006/relationships" id="256" r:id="R09eb546892ea4171"/>
-    <p:sldId xmlns:r="http://schemas.openxmlformats.org/officeDocument/2006/relationships" id="257" r:id="Rbed0ae2579be41f6"/>
-    <p:sldId xmlns:r="http://schemas.openxmlformats.org/officeDocument/2006/relationships" id="258" r:id="R2d6a7dc8cb18496d"/>
-    <p:sldId xmlns:r="http://schemas.openxmlformats.org/officeDocument/2006/relationships" id="259" r:id="Rcf0fbdf96be54f91"/>
-    <p:sldId xmlns:r="http://schemas.openxmlformats.org/officeDocument/2006/relationships" id="260" r:id="Ra5125ff2d7574f81"/>
-    <p:sldId xmlns:r="http://schemas.openxmlformats.org/officeDocument/2006/relationships" id="261" r:id="Ra3bb8b779cd64672"/>
-    <p:sldId xmlns:r="http://schemas.openxmlformats.org/officeDocument/2006/relationships" id="262" r:id="R71f8b06e0ce0476b"/>
+    <p:sldId xmlns:r="http://schemas.openxmlformats.org/officeDocument/2006/relationships" id="256" r:id="R7b9ca3c1be124e07"/>
+    <p:sldId xmlns:r="http://schemas.openxmlformats.org/officeDocument/2006/relationships" id="257" r:id="R308d510860bc4dda"/>
+    <p:sldId xmlns:r="http://schemas.openxmlformats.org/officeDocument/2006/relationships" id="258" r:id="Re8e4bbe5d4e047e4"/>
+    <p:sldId xmlns:r="http://schemas.openxmlformats.org/officeDocument/2006/relationships" id="259" r:id="Radf8b61931524708"/>
+    <p:sldId xmlns:r="http://schemas.openxmlformats.org/officeDocument/2006/relationships" id="260" r:id="Rd9f6ba0c189b493e"/>
+    <p:sldId xmlns:r="http://schemas.openxmlformats.org/officeDocument/2006/relationships" id="261" r:id="R1feac78dd4d84fa9"/>
+    <p:sldId xmlns:r="http://schemas.openxmlformats.org/officeDocument/2006/relationships" id="262" r:id="R097c3d3598334d56"/>
   </p:sldIdLst>
   <p:sldSz cx="12192000" cy="6858000"/>
   <p:notesSz cx="6858000" cy="9144000"/>
@@ -258,7 +258,7 @@
 </p:notesMaster>
 </file>
 
-<file path=ppt/notesMasters/theme/theme2.xml><?xml version="1.0" encoding="utf-8"?>
+<file path=ppt/notesMasters/theme/theme3.xml><?xml version="1.0" encoding="utf-8"?>
 <a:theme xmlns:a="http://schemas.openxmlformats.org/drawingml/2006/main" name="ChatGPT">
   <a:themeElements>
     <a:clrScheme name="ChatGPT">
@@ -1008,10 +1008,10 @@
   </p:cSld>
   <p:clrMap bg1="lt1" tx1="dk1" bg2="lt2" tx2="dk2" accent1="accent1" accent2="accent2" accent3="accent3" accent4="accent4" accent5="accent5" accent6="accent6" hlink="hlink" folHlink="folHlink"/>
   <p:sldLayoutIdLst>
-    <p:sldLayoutId xmlns:r="http://schemas.openxmlformats.org/officeDocument/2006/relationships" id="2147483648" r:id="R0c88bb15bfaf4987"/>
-    <p:sldLayoutId xmlns:r="http://schemas.openxmlformats.org/officeDocument/2006/relationships" id="2147483649" r:id="Raf21372b77c1488e"/>
-    <p:sldLayoutId xmlns:r="http://schemas.openxmlformats.org/officeDocument/2006/relationships" id="2147483650" r:id="Rb83012f381d24885"/>
-    <p:sldLayoutId xmlns:r="http://schemas.openxmlformats.org/officeDocument/2006/relationships" id="2147483651" r:id="R5a961220e3dc47c8"/>
+    <p:sldLayoutId xmlns:r="http://schemas.openxmlformats.org/officeDocument/2006/relationships" id="2147483649" r:id="Rc7bb486b4cf74b52"/>
+    <p:sldLayoutId xmlns:r="http://schemas.openxmlformats.org/officeDocument/2006/relationships" id="2147483650" r:id="Radb984f7bfcd41b6"/>
+    <p:sldLayoutId xmlns:r="http://schemas.openxmlformats.org/officeDocument/2006/relationships" id="2147483651" r:id="R786fda7f63c84e6c"/>
+    <p:sldLayoutId xmlns:r="http://schemas.openxmlformats.org/officeDocument/2006/relationships" id="2147483652" r:id="R8100f967b3104ac6"/>
   </p:sldLayoutIdLst>
   <p:txStyles>
     <p:titleStyle>
@@ -1293,6 +1293,205 @@
 </p:sldMaster>
 </file>
 
+<file path=ppt/slideMasters/theme/theme2.xml><?xml version="1.0" encoding="utf-8"?>
+<a:theme xmlns:a="http://schemas.openxmlformats.org/drawingml/2006/main" name="ChatGPT">
+  <a:themeElements>
+    <a:clrScheme name="ChatGPT">
+      <a:dk1>
+        <a:srgbClr val="000000"/>
+      </a:dk1>
+      <a:lt1>
+        <a:srgbClr val="FFFFFF"/>
+      </a:lt1>
+      <a:dk2>
+        <a:srgbClr val="0E2841"/>
+      </a:dk2>
+      <a:lt2>
+        <a:srgbClr val="E8E8E8"/>
+      </a:lt2>
+      <a:accent1>
+        <a:srgbClr val="156082"/>
+      </a:accent1>
+      <a:accent2>
+        <a:srgbClr val="E97132"/>
+      </a:accent2>
+      <a:accent3>
+        <a:srgbClr val="196B24"/>
+      </a:accent3>
+      <a:accent4>
+        <a:srgbClr val="0F9ED5"/>
+      </a:accent4>
+      <a:accent5>
+        <a:srgbClr val="A02B93"/>
+      </a:accent5>
+      <a:accent6>
+        <a:srgbClr val="4EA72E"/>
+      </a:accent6>
+      <a:hlink>
+        <a:srgbClr val="467886"/>
+      </a:hlink>
+      <a:folHlink>
+        <a:srgbClr val="96607D"/>
+      </a:folHlink>
+    </a:clrScheme>
+    <a:fontScheme name="Office">
+      <a:majorFont>
+        <a:latin typeface="Calibri Light"/>
+        <a:ea typeface="Calibri Light"/>
+        <a:cs typeface="Calibri Light"/>
+      </a:majorFont>
+      <a:minorFont>
+        <a:latin typeface="Calibri"/>
+        <a:ea typeface="Calibri"/>
+        <a:cs typeface="Calibri"/>
+      </a:minorFont>
+    </a:fontScheme>
+    <a:fmtScheme name="ChatGPT">
+      <a:fillStyleLst>
+        <a:solidFill>
+          <a:schemeClr val="phClr"/>
+        </a:solidFill>
+        <a:solidFill>
+          <a:schemeClr val="dk1"/>
+        </a:solidFill>
+        <a:solidFill>
+          <a:schemeClr val="accent1"/>
+        </a:solidFill>
+      </a:fillStyleLst>
+      <a:lnStyleLst>
+        <a:ln w="12700">
+          <a:solidFill>
+            <a:schemeClr val="phClr"/>
+          </a:solidFill>
+          <a:prstDash val="solid"/>
+        </a:ln>
+        <a:ln w="19050">
+          <a:solidFill>
+            <a:schemeClr val="phClr"/>
+          </a:solidFill>
+          <a:prstDash val="solid"/>
+        </a:ln>
+        <a:ln w="25400">
+          <a:solidFill>
+            <a:schemeClr val="phClr"/>
+          </a:solidFill>
+          <a:prstDash val="solid"/>
+        </a:ln>
+      </a:lnStyleLst>
+      <a:effectStyleLst>
+        <a:effectStyle>
+          <a:effectLst/>
+        </a:effectStyle>
+        <a:effectStyle>
+          <a:effectLst/>
+        </a:effectStyle>
+        <a:effectStyle>
+          <a:effectLst>
+            <a:outerShdw blurRad="57150" dist="19050" dir="5400000">
+              <a:srgbClr val="000000">
+                <a:alpha val="16000"/>
+              </a:srgbClr>
+            </a:outerShdw>
+          </a:effectLst>
+        </a:effectStyle>
+        <a:effectStyle>
+          <a:effectLst>
+            <a:outerShdw blurRad="19050" dist="9525" dir="5400000">
+              <a:srgbClr val="000000">
+                <a:alpha val="6000"/>
+              </a:srgbClr>
+            </a:outerShdw>
+          </a:effectLst>
+        </a:effectStyle>
+        <a:effectStyle>
+          <a:effectLst>
+            <a:outerShdw blurRad="28575" dist="9525" dir="5400000">
+              <a:srgbClr val="000000">
+                <a:alpha val="8000"/>
+              </a:srgbClr>
+            </a:outerShdw>
+          </a:effectLst>
+        </a:effectStyle>
+        <a:effectStyle>
+          <a:effectLst>
+            <a:outerShdw blurRad="57150" dist="19050" dir="5400000">
+              <a:srgbClr val="000000">
+                <a:alpha val="10000"/>
+              </a:srgbClr>
+            </a:outerShdw>
+          </a:effectLst>
+        </a:effectStyle>
+        <a:effectStyle>
+          <a:effectLst>
+            <a:outerShdw blurRad="114300" dist="38100" dir="5400000">
+              <a:srgbClr val="000000">
+                <a:alpha val="12000"/>
+              </a:srgbClr>
+            </a:outerShdw>
+          </a:effectLst>
+        </a:effectStyle>
+        <a:effectStyle>
+          <a:effectLst>
+            <a:outerShdw blurRad="171450" dist="57150" dir="5400000">
+              <a:srgbClr val="000000">
+                <a:alpha val="16000"/>
+              </a:srgbClr>
+            </a:outerShdw>
+          </a:effectLst>
+        </a:effectStyle>
+        <a:effectStyle>
+          <a:effectLst>
+            <a:outerShdw blurRad="266700" dist="95250" dir="5400000">
+              <a:srgbClr val="000000">
+                <a:alpha val="24000"/>
+              </a:srgbClr>
+            </a:outerShdw>
+          </a:effectLst>
+        </a:effectStyle>
+      </a:effectStyleLst>
+      <a:bgFillStyleLst>
+        <a:solidFill>
+          <a:schemeClr val="phClr"/>
+        </a:solidFill>
+        <a:solidFill>
+          <a:schemeClr val="phClr">
+            <a:tint val="95000"/>
+            <a:satMod val="170000"/>
+          </a:schemeClr>
+        </a:solidFill>
+        <a:gradFill>
+          <a:gsLst>
+            <a:gs pos="0">
+              <a:schemeClr val="phClr">
+                <a:tint val="93000"/>
+                <a:shade val="98000"/>
+                <a:lumMod val="102000"/>
+                <a:satMod val="150000"/>
+              </a:schemeClr>
+            </a:gs>
+            <a:gs pos="50000">
+              <a:schemeClr val="phClr">
+                <a:tint val="98000"/>
+                <a:shade val="90000"/>
+                <a:lumMod val="103000"/>
+                <a:satMod val="130000"/>
+              </a:schemeClr>
+            </a:gs>
+            <a:gs pos="100000">
+              <a:schemeClr val="phClr">
+                <a:shade val="63000"/>
+                <a:satMod val="120000"/>
+              </a:schemeClr>
+            </a:gs>
+          </a:gsLst>
+          <a:lin ang="5400000" scaled="0"/>
+        </a:gradFill>
+      </a:bgFillStyleLst>
+    </a:fmtScheme>
+  </a:themeElements>
+</a:theme>
+</file>
+
 <file path=ppt/slides/slide1.xml><?xml version="1.0" encoding="utf-8"?>
 <p:sld xmlns:p="http://schemas.openxmlformats.org/presentationml/2006/main">
   <p:cSld>
@@ -2659,7 +2858,7 @@
               </a:defRPr>
             </a:pPr>
             <a:r>
-              <a:t>算法大作业</a:t>
+              <a:t>量子信息基础大作业</a:t>
             </a:r>
           </a:p>
         </p:txBody>
@@ -9948,6 +10147,7 @@
           <a:lstStyle xmlns:a="http://schemas.openxmlformats.org/drawingml/2006/main"/>
           <a:p xmlns:a="http://schemas.openxmlformats.org/drawingml/2006/main">
             <a:pPr algn="l">
+              <a:buNone/>
               <a:defRPr sz="1050" b="1">
                 <a:solidFill>
                   <a:srgbClr val="8EA0B8"/>
@@ -10004,6 +10204,7 @@
           <a:lstStyle xmlns:a="http://schemas.openxmlformats.org/drawingml/2006/main"/>
           <a:p xmlns:a="http://schemas.openxmlformats.org/drawingml/2006/main">
             <a:pPr algn="l">
+              <a:buNone/>
               <a:defRPr sz="2850" b="1">
                 <a:solidFill>
                   <a:srgbClr val="FFFFFF"/>
@@ -10021,14 +10222,14 @@
       </p:sp>
       <p:pic>
         <p:nvPicPr>
-          <p:cNvPr id="5" name=""/>
+          <p:cNvPr id="21" name=""/>
           <p:cNvPicPr>
             <a:picLocks xmlns:a="http://schemas.openxmlformats.org/drawingml/2006/main" noChangeAspect="1"/>
           </p:cNvPicPr>
           <p:nvPr/>
         </p:nvPicPr>
         <p:blipFill>
-          <a:blip xmlns:r="http://schemas.openxmlformats.org/officeDocument/2006/relationships" xmlns:a="http://schemas.openxmlformats.org/drawingml/2006/main" r:embed="R8f5f054675304068"/>
+          <a:blip xmlns:r="http://schemas.openxmlformats.org/officeDocument/2006/relationships" xmlns:a="http://schemas.openxmlformats.org/drawingml/2006/main" r:embed="R3a1e30cd679f4f5f"/>
           <a:srcRect xmlns:a="http://schemas.openxmlformats.org/drawingml/2006/main" l="0" t="21506" r="0" b="21506"/>
           <a:stretch xmlns:a="http://schemas.openxmlformats.org/drawingml/2006/main">
             <a:fillRect l="0" t="0" r="0" b="0"/>
@@ -10118,6 +10319,7 @@
           <a:lstStyle xmlns:a="http://schemas.openxmlformats.org/drawingml/2006/main"/>
           <a:p xmlns:a="http://schemas.openxmlformats.org/drawingml/2006/main">
             <a:pPr algn="l">
+              <a:buNone/>
               <a:defRPr sz="1350" b="1">
                 <a:solidFill>
                   <a:srgbClr val="47D6C8"/>
@@ -10172,6 +10374,7 @@
           <a:lstStyle xmlns:a="http://schemas.openxmlformats.org/drawingml/2006/main"/>
           <a:p xmlns:a="http://schemas.openxmlformats.org/drawingml/2006/main">
             <a:pPr algn="l">
+              <a:buNone/>
               <a:defRPr sz="1125" b="0">
                 <a:solidFill>
                   <a:srgbClr val="FFFFFF"/>
@@ -10187,6 +10390,7 @@
           </a:p>
           <a:p xmlns:a="http://schemas.openxmlformats.org/drawingml/2006/main">
             <a:pPr algn="l">
+              <a:buNone/>
               <a:defRPr sz="1125" b="0">
                 <a:solidFill>
                   <a:srgbClr val="FFFFFF"/>
@@ -10276,6 +10480,7 @@
           <a:lstStyle xmlns:a="http://schemas.openxmlformats.org/drawingml/2006/main"/>
           <a:p xmlns:a="http://schemas.openxmlformats.org/drawingml/2006/main">
             <a:pPr algn="l">
+              <a:buNone/>
               <a:defRPr sz="1350" b="1">
                 <a:solidFill>
                   <a:srgbClr val="7DDC8A"/>
@@ -10330,6 +10535,7 @@
           <a:lstStyle xmlns:a="http://schemas.openxmlformats.org/drawingml/2006/main"/>
           <a:p xmlns:a="http://schemas.openxmlformats.org/drawingml/2006/main">
             <a:pPr algn="l">
+              <a:buNone/>
               <a:defRPr sz="1125" b="0">
                 <a:solidFill>
                   <a:srgbClr val="FFFFFF"/>
@@ -10419,6 +10625,7 @@
           <a:lstStyle xmlns:a="http://schemas.openxmlformats.org/drawingml/2006/main"/>
           <a:p xmlns:a="http://schemas.openxmlformats.org/drawingml/2006/main">
             <a:pPr algn="l">
+              <a:buNone/>
               <a:defRPr sz="1350" b="1">
                 <a:solidFill>
                   <a:srgbClr val="F2B84B"/>
@@ -10473,6 +10680,7 @@
           <a:lstStyle xmlns:a="http://schemas.openxmlformats.org/drawingml/2006/main"/>
           <a:p xmlns:a="http://schemas.openxmlformats.org/drawingml/2006/main">
             <a:pPr algn="l">
+              <a:buNone/>
               <a:defRPr sz="1125" b="0">
                 <a:solidFill>
                   <a:srgbClr val="FFFFFF"/>
@@ -10529,6 +10737,7 @@
           <a:lstStyle xmlns:a="http://schemas.openxmlformats.org/drawingml/2006/main"/>
           <a:p xmlns:a="http://schemas.openxmlformats.org/drawingml/2006/main">
             <a:pPr algn="l">
+              <a:buNone/>
               <a:defRPr sz="900" b="0">
                 <a:solidFill>
                   <a:srgbClr val="8EA0B8"/>

</xml_diff>